<commit_message>
CA-CSS v4 부록 PPT 수정 — physics loss vs 구조 prior 정리
ca-css-ncmapss 결과를 반영해 부록 deck(5장)과 figure 생성 경로를 고치고,
v7/DX 관련 extrapolation-papers 자료를 함께 업데이트한다.

Co-authored-by: Cursor <cursoragent@cursor.com>
</commit_message>
<xml_diff>
--- a/extrapolation-papers/외삽_50분_사례_CA-CSS_v4_부록.pptx
+++ b/extrapolation-papers/외삽_50분_사례_CA-CSS_v4_부록.pptx
@@ -9,6 +9,7 @@
     <p:sldId id="257" r:id="rId8"/>
     <p:sldId id="258" r:id="rId9"/>
     <p:sldId id="259" r:id="rId10"/>
+    <p:sldId id="260" r:id="rId11"/>
   </p:sldIdLst>
   <p:sldSz cx="12191695" cy="6858000" type="screen4x3"/>
   <p:notesSz cx="6858000" cy="9144000"/>
@@ -3208,7 +3209,7 @@
                 <a:latin typeface="Apple SD Gothic Neo"/>
                 <a:ea typeface="Apple SD Gothic Neo"/>
               </a:rPr>
-              <a:t>사례 1/4</a:t>
+              <a:t>사례 1/5</a:t>
             </a:r>
           </a:p>
         </p:txBody>
@@ -3358,7 +3359,7 @@
                 <a:latin typeface="Apple SD Gothic Neo"/>
                 <a:ea typeface="Apple SD Gothic Neo"/>
               </a:rPr>
-              <a:t>1 / 4</a:t>
+              <a:t>1 / 5</a:t>
             </a:r>
           </a:p>
         </p:txBody>
@@ -3552,7 +3553,7 @@
                 <a:latin typeface="Apple SD Gothic Neo"/>
                 <a:ea typeface="Apple SD Gothic Neo"/>
               </a:rPr>
-              <a:t>•  라벨은 ‘몇 cycle 남았나’만 — 순간 부하와는 무관</a:t>
+              <a:t>•  라벨은 ‘몇 cycle 남았나’ — 순간 TRA와 무관 (∂RUL/∂TRA=0)</a:t>
             </a:r>
           </a:p>
         </p:txBody>
@@ -3729,7 +3730,7 @@
                 <a:latin typeface="Apple SD Gothic Neo"/>
                 <a:ea typeface="Apple SD Gothic Neo"/>
               </a:rPr>
-              <a:t>•  새 엔진과 새 부하가 동시에 옴 (n≈159)</a:t>
+              <a:t>•  새 엔진 + 새 부하 동시 (n≈159 windows)</a:t>
             </a:r>
           </a:p>
           <a:p>
@@ -3746,7 +3747,7 @@
                 <a:latin typeface="Apple SD Gothic Neo"/>
                 <a:ea typeface="Apple SD Gothic Neo"/>
               </a:rPr>
-              <a:t>•  여기서 TabPFN 4.8, LSTM 15 epoch는 16 전후</a:t>
+              <a:t>•  fair epoch: v4 e15 · LSTM/Trans e120 → TabPFN 4.8대</a:t>
             </a:r>
           </a:p>
         </p:txBody>
@@ -3760,7 +3761,7 @@
         <p:spPr>
           <a:xfrm>
             <a:off x="4617720" y="1005840"/>
-            <a:ext cx="7287768" cy="3510950"/>
+            <a:ext cx="7287768" cy="3532541"/>
           </a:xfrm>
           <a:prstGeom prst="roundRect">
             <a:avLst>
@@ -3815,7 +3816,7 @@
         <p:spPr>
           <a:xfrm>
             <a:off x="4672584" y="1060704"/>
-            <a:ext cx="7178040" cy="3401222"/>
+            <a:ext cx="7178040" cy="3422813"/>
           </a:xfrm>
           <a:prstGeom prst="rect">
             <a:avLst/>
@@ -3830,7 +3831,7 @@
         </p:nvSpPr>
         <p:spPr>
           <a:xfrm>
-            <a:off x="4617720" y="4535078"/>
+            <a:off x="4617720" y="4556669"/>
             <a:ext cx="7287768" cy="219456"/>
           </a:xfrm>
           <a:prstGeom prst="rect">
@@ -3979,7 +3980,7 @@
                 <a:latin typeface="Apple SD Gothic Neo"/>
                 <a:ea typeface="Apple SD Gothic Neo"/>
               </a:rPr>
-              <a:t>그림·수치는 훈련·검증이 아니라, 시험(외삽) 구간만을 말한다</a:t>
+              <a:t>hard = unit×regime 결합 외삽 — 여기서만 headline 주장</a:t>
             </a:r>
           </a:p>
         </p:txBody>
@@ -4119,7 +4120,7 @@
                 <a:latin typeface="Apple SD Gothic Neo"/>
                 <a:ea typeface="Apple SD Gothic Neo"/>
               </a:rPr>
-              <a:t>사례 2/4</a:t>
+              <a:t>사례 2/5</a:t>
             </a:r>
           </a:p>
         </p:txBody>
@@ -4155,7 +4156,7 @@
                 <a:latin typeface="Apple SD Gothic Neo"/>
                 <a:ea typeface="Apple SD Gothic Neo"/>
               </a:rPr>
-              <a:t>CA-CSS v4 구조와 구성요소별 설계 의도</a:t>
+              <a:t>CA-CSS v4 구조 — 방향은 아키텍처에 내장</a:t>
             </a:r>
           </a:p>
         </p:txBody>
@@ -4233,7 +4234,7 @@
                 <a:latin typeface="Apple SD Gothic Neo"/>
                 <a:ea typeface="Apple SD Gothic Neo"/>
               </a:rPr>
-              <a:t>CA-CSS v4 Case Appendix  ·  Kookmin Univ. IE Lab  ·  2026  ·  위: 블록 다이어그램 · 아래: 가정 → 설계 매핑.</a:t>
+              <a:t>CA-CSS v4 Case Appendix  ·  Kookmin Univ. IE Lab  ·  2026  ·  본편 S20 CMNN echo: loss가 아니라 구조가 prior.</a:t>
             </a:r>
           </a:p>
         </p:txBody>
@@ -4269,7 +4270,7 @@
                 <a:latin typeface="Apple SD Gothic Neo"/>
                 <a:ea typeface="Apple SD Gothic Neo"/>
               </a:rPr>
-              <a:t>2 / 4</a:t>
+              <a:t>2 / 5</a:t>
             </a:r>
           </a:p>
         </p:txBody>
@@ -4282,8 +4283,8 @@
         </p:nvSpPr>
         <p:spPr>
           <a:xfrm>
-            <a:off x="1097280" y="914400"/>
-            <a:ext cx="8388945" cy="2441448"/>
+            <a:off x="384048" y="914400"/>
+            <a:ext cx="8064270" cy="2350008"/>
           </a:xfrm>
           <a:prstGeom prst="roundRect">
             <a:avLst>
@@ -4337,8 +4338,8 @@
         </p:blipFill>
         <p:spPr>
           <a:xfrm>
-            <a:off x="1152144" y="969264"/>
-            <a:ext cx="8279217" cy="2331720"/>
+            <a:off x="438912" y="969264"/>
+            <a:ext cx="7954542" cy="2240280"/>
           </a:xfrm>
           <a:prstGeom prst="rect">
             <a:avLst/>
@@ -4353,8 +4354,8 @@
         </p:nvSpPr>
         <p:spPr>
           <a:xfrm>
-            <a:off x="1097280" y="3374136"/>
-            <a:ext cx="8388945" cy="219456"/>
+            <a:off x="384048" y="3282696"/>
+            <a:ext cx="8064270" cy="219456"/>
           </a:xfrm>
           <a:prstGeom prst="rect">
             <a:avLst/>
@@ -4376,7 +4377,7 @@
                 <a:latin typeface="Apple SD Gothic Neo"/>
                 <a:ea typeface="Apple SD Gothic Neo"/>
               </a:rPr>
-              <a:t>health ∥ damage → RUL=H−D · mono∥MLP · isotonic</a:t>
+              <a:t>RUL=H−D · health TRA-blind · MonotoneLoadHead</a:t>
             </a:r>
           </a:p>
         </p:txBody>
@@ -4390,8 +4391,8 @@
           <p:nvPr/>
         </p:nvGraphicFramePr>
         <p:xfrm>
-          <a:off x="384048" y="3456432"/>
-          <a:ext cx="5623560" cy="1536192"/>
+          <a:off x="384048" y="3310128"/>
+          <a:ext cx="5623560" cy="1408176"/>
         </p:xfrm>
         <a:graphic>
           <a:graphicData uri="http://schemas.openxmlformats.org/drawingml/2006/table">
@@ -4400,18 +4401,18 @@
                 <a:tableStyleId>{5C22544A-7EE6-4342-B048-85BDC9FD1C3A}</a:tableStyleId>
               </a:tblPr>
               <a:tblGrid>
-                <a:gridCol w="1234440"/>
-                <a:gridCol w="1691640"/>
+                <a:gridCol w="1325880"/>
+                <a:gridCol w="1600200"/>
                 <a:gridCol w="2697480"/>
               </a:tblGrid>
-              <a:tr h="219456">
+              <a:tr h="201168">
                 <a:tc>
                   <a:txBody>
                     <a:bodyPr/>
                     <a:lstStyle/>
                     <a:p>
                       <a:r>
-                        <a:rPr sz="800" b="1">
+                        <a:rPr sz="750" b="1">
                           <a:solidFill>
                             <a:srgbClr val="3DD6C6"/>
                           </a:solidFill>
@@ -4430,7 +4431,7 @@
                     <a:lstStyle/>
                     <a:p>
                       <a:r>
-                        <a:rPr sz="800" b="1">
+                        <a:rPr sz="750" b="1">
                           <a:solidFill>
                             <a:srgbClr val="3DD6C6"/>
                           </a:solidFill>
@@ -4449,7 +4450,7 @@
                     <a:lstStyle/>
                     <a:p>
                       <a:r>
-                        <a:rPr sz="800" b="1">
+                        <a:rPr sz="750" b="1">
                           <a:solidFill>
                             <a:srgbClr val="3DD6C6"/>
                           </a:solidFill>
@@ -4463,14 +4464,14 @@
                   <a:tcPr/>
                 </a:tc>
               </a:tr>
-              <a:tr h="219456">
+              <a:tr h="201168">
                 <a:tc>
                   <a:txBody>
                     <a:bodyPr/>
                     <a:lstStyle/>
                     <a:p>
                       <a:r>
-                        <a:rPr sz="800" b="1">
+                        <a:rPr sz="750" b="1">
                           <a:solidFill>
                             <a:srgbClr val="ECF1F7"/>
                           </a:solidFill>
@@ -4489,7 +4490,7 @@
                     <a:lstStyle/>
                     <a:p>
                       <a:r>
-                        <a:rPr sz="800" b="0">
+                        <a:rPr sz="750" b="0">
                           <a:solidFill>
                             <a:srgbClr val="A0ADBC"/>
                           </a:solidFill>
@@ -4508,7 +4509,7 @@
                     <a:lstStyle/>
                     <a:p>
                       <a:r>
-                        <a:rPr sz="800" b="0">
+                        <a:rPr sz="750" b="0">
                           <a:solidFill>
                             <a:srgbClr val="A0ADBC"/>
                           </a:solidFill>
@@ -4522,14 +4523,14 @@
                   <a:tcPr/>
                 </a:tc>
               </a:tr>
-              <a:tr h="219456">
+              <a:tr h="201168">
                 <a:tc>
                   <a:txBody>
                     <a:bodyPr/>
                     <a:lstStyle/>
                     <a:p>
                       <a:r>
-                        <a:rPr sz="800" b="1">
+                        <a:rPr sz="750" b="1">
                           <a:solidFill>
                             <a:srgbClr val="ECF1F7"/>
                           </a:solidFill>
@@ -4548,7 +4549,7 @@
                     <a:lstStyle/>
                     <a:p>
                       <a:r>
-                        <a:rPr sz="800" b="0">
+                        <a:rPr sz="750" b="0">
                           <a:solidFill>
                             <a:srgbClr val="A0ADBC"/>
                           </a:solidFill>
@@ -4567,7 +4568,7 @@
                     <a:lstStyle/>
                     <a:p>
                       <a:r>
-                        <a:rPr sz="800" b="0">
+                        <a:rPr sz="750" b="0">
                           <a:solidFill>
                             <a:srgbClr val="A0ADBC"/>
                           </a:solidFill>
@@ -4581,14 +4582,14 @@
                   <a:tcPr/>
                 </a:tc>
               </a:tr>
-              <a:tr h="219456">
+              <a:tr h="201168">
                 <a:tc>
                   <a:txBody>
                     <a:bodyPr/>
                     <a:lstStyle/>
                     <a:p>
                       <a:r>
-                        <a:rPr sz="800" b="1">
+                        <a:rPr sz="750" b="1">
                           <a:solidFill>
                             <a:srgbClr val="ECF1F7"/>
                           </a:solidFill>
@@ -4607,7 +4608,7 @@
                     <a:lstStyle/>
                     <a:p>
                       <a:r>
-                        <a:rPr sz="800" b="0">
+                        <a:rPr sz="750" b="0">
                           <a:solidFill>
                             <a:srgbClr val="A0ADBC"/>
                           </a:solidFill>
@@ -4626,35 +4627,35 @@
                     <a:lstStyle/>
                     <a:p>
                       <a:r>
-                        <a:rPr sz="800" b="0">
+                        <a:rPr sz="750" b="0">
                           <a:solidFill>
                             <a:srgbClr val="A0ADBC"/>
                           </a:solidFill>
                           <a:latin typeface="Apple SD Gothic Neo"/>
                           <a:ea typeface="Apple SD Gothic Neo"/>
                         </a:rPr>
-                        <a:t>TRA→0 지름길 차단</a:t>
+                        <a:t>health 경로 TRA→0</a:t>
                       </a:r>
                     </a:p>
                   </a:txBody>
                   <a:tcPr/>
                 </a:tc>
               </a:tr>
-              <a:tr h="219456">
+              <a:tr h="201168">
                 <a:tc>
                   <a:txBody>
                     <a:bodyPr/>
                     <a:lstStyle/>
                     <a:p>
                       <a:r>
-                        <a:rPr sz="800" b="1">
+                        <a:rPr sz="750" b="1">
                           <a:solidFill>
                             <a:srgbClr val="ECF1F7"/>
                           </a:solidFill>
                           <a:latin typeface="Apple SD Gothic Neo"/>
                           <a:ea typeface="Apple SD Gothic Neo"/>
                         </a:rPr>
-                        <a:t>Linear 33→64</a:t>
+                        <a:t>Transformer×2</a:t>
                       </a:r>
                     </a:p>
                   </a:txBody>
@@ -4666,7 +4667,388 @@
                     <a:lstStyle/>
                     <a:p>
                       <a:r>
-                        <a:rPr sz="800" b="0">
+                        <a:rPr sz="750" b="0">
+                          <a:solidFill>
+                            <a:srgbClr val="A0ADBC"/>
+                          </a:solidFill>
+                          <a:latin typeface="Apple SD Gothic Neo"/>
+                          <a:ea typeface="Apple SD Gothic Neo"/>
+                        </a:rPr>
+                        <a:t>열화 시간 누적</a:t>
+                      </a:r>
+                    </a:p>
+                  </a:txBody>
+                  <a:tcPr/>
+                </a:tc>
+                <a:tc>
+                  <a:txBody>
+                    <a:bodyPr/>
+                    <a:lstStyle/>
+                    <a:p>
+                      <a:r>
+                        <a:rPr sz="750" b="0">
+                          <a:solidFill>
+                            <a:srgbClr val="A0ADBC"/>
+                          </a:solidFill>
+                          <a:latin typeface="Apple SD Gothic Neo"/>
+                          <a:ea typeface="Apple SD Gothic Neo"/>
+                        </a:rPr>
+                        <a:t>MHA 시계열 의존</a:t>
+                      </a:r>
+                    </a:p>
+                  </a:txBody>
+                  <a:tcPr/>
+                </a:tc>
+              </a:tr>
+              <a:tr h="201168">
+                <a:tc>
+                  <a:txBody>
+                    <a:bodyPr/>
+                    <a:lstStyle/>
+                    <a:p>
+                      <a:r>
+                        <a:rPr sz="750" b="1">
+                          <a:solidFill>
+                            <a:srgbClr val="ECF1F7"/>
+                          </a:solidFill>
+                          <a:latin typeface="Apple SD Gothic Neo"/>
+                          <a:ea typeface="Apple SD Gothic Neo"/>
+                        </a:rPr>
+                        <a:t>Health Head → H</a:t>
+                      </a:r>
+                    </a:p>
+                  </a:txBody>
+                  <a:tcPr/>
+                </a:tc>
+                <a:tc>
+                  <a:txBody>
+                    <a:bodyPr/>
+                    <a:lstStyle/>
+                    <a:p>
+                      <a:r>
+                        <a:rPr sz="750" b="0">
+                          <a:solidFill>
+                            <a:srgbClr val="A0ADBC"/>
+                          </a:solidFill>
+                          <a:latin typeface="Apple SD Gothic Neo"/>
+                          <a:ea typeface="Apple SD Gothic Neo"/>
+                        </a:rPr>
+                        <a:t>H &gt; 0</a:t>
+                      </a:r>
+                    </a:p>
+                  </a:txBody>
+                  <a:tcPr/>
+                </a:tc>
+                <a:tc>
+                  <a:txBody>
+                    <a:bodyPr/>
+                    <a:lstStyle/>
+                    <a:p>
+                      <a:r>
+                        <a:rPr sz="750" b="0">
+                          <a:solidFill>
+                            <a:srgbClr val="A0ADBC"/>
+                          </a:solidFill>
+                          <a:latin typeface="Apple SD Gothic Neo"/>
+                          <a:ea typeface="Apple SD Gothic Neo"/>
+                        </a:rPr>
+                        <a:t>softplus 잠재 건강</a:t>
+                      </a:r>
+                    </a:p>
+                  </a:txBody>
+                  <a:tcPr/>
+                </a:tc>
+              </a:tr>
+              <a:tr h="201168">
+                <a:tc>
+                  <a:txBody>
+                    <a:bodyPr/>
+                    <a:lstStyle/>
+                    <a:p>
+                      <a:r>
+                        <a:rPr sz="750" b="1">
+                          <a:solidFill>
+                            <a:srgbClr val="ECF1F7"/>
+                          </a:solidFill>
+                          <a:latin typeface="Apple SD Gothic Neo"/>
+                          <a:ea typeface="Apple SD Gothic Neo"/>
+                        </a:rPr>
+                        <a:t>MonotoneLoadHead</a:t>
+                      </a:r>
+                    </a:p>
+                  </a:txBody>
+                  <a:tcPr/>
+                </a:tc>
+                <a:tc>
+                  <a:txBody>
+                    <a:bodyPr/>
+                    <a:lstStyle/>
+                    <a:p>
+                      <a:r>
+                        <a:rPr sz="750" b="0">
+                          <a:solidFill>
+                            <a:srgbClr val="A0ADBC"/>
+                          </a:solidFill>
+                          <a:latin typeface="Apple SD Gothic Neo"/>
+                          <a:ea typeface="Apple SD Gothic Neo"/>
+                        </a:rPr>
+                        <a:t>TRA↑→D↑</a:t>
+                      </a:r>
+                    </a:p>
+                  </a:txBody>
+                  <a:tcPr/>
+                </a:tc>
+                <a:tc>
+                  <a:txBody>
+                    <a:bodyPr/>
+                    <a:lstStyle/>
+                    <a:p>
+                      <a:r>
+                        <a:rPr sz="750" b="0">
+                          <a:solidFill>
+                            <a:srgbClr val="A0ADBC"/>
+                          </a:solidFill>
+                          <a:latin typeface="Apple SD Gothic Neo"/>
+                          <a:ea typeface="Apple SD Gothic Neo"/>
+                        </a:rPr>
+                        <a:t>∂RUL/∂TRA&lt;0 **구조 항등식**</a:t>
+                      </a:r>
+                    </a:p>
+                  </a:txBody>
+                  <a:tcPr/>
+                </a:tc>
+              </a:tr>
+            </a:tbl>
+          </a:graphicData>
+        </a:graphic>
+      </p:graphicFrame>
+      <p:graphicFrame>
+        <p:nvGraphicFramePr>
+          <p:cNvPr id="13" name="Table 12"/>
+          <p:cNvGraphicFramePr>
+            <a:graphicFrameLocks noGrp="1"/>
+          </p:cNvGraphicFramePr>
+          <p:nvPr/>
+        </p:nvGraphicFramePr>
+        <p:xfrm>
+          <a:off x="6172200" y="3310128"/>
+          <a:ext cx="5623560" cy="1005840"/>
+        </p:xfrm>
+        <a:graphic>
+          <a:graphicData uri="http://schemas.openxmlformats.org/drawingml/2006/table">
+            <a:tbl>
+              <a:tblPr firstRow="1" bandRow="1">
+                <a:tableStyleId>{5C22544A-7EE6-4342-B048-85BDC9FD1C3A}</a:tableStyleId>
+              </a:tblPr>
+              <a:tblGrid>
+                <a:gridCol w="1325880"/>
+                <a:gridCol w="1600200"/>
+                <a:gridCol w="2697480"/>
+              </a:tblGrid>
+              <a:tr h="201168">
+                <a:tc>
+                  <a:txBody>
+                    <a:bodyPr/>
+                    <a:lstStyle/>
+                    <a:p>
+                      <a:r>
+                        <a:rPr sz="750" b="1">
+                          <a:solidFill>
+                            <a:srgbClr val="3DD6C6"/>
+                          </a:solidFill>
+                          <a:latin typeface="Apple SD Gothic Neo"/>
+                          <a:ea typeface="Apple SD Gothic Neo"/>
+                        </a:rPr>
+                        <a:t>구성요소</a:t>
+                      </a:r>
+                    </a:p>
+                  </a:txBody>
+                  <a:tcPr/>
+                </a:tc>
+                <a:tc>
+                  <a:txBody>
+                    <a:bodyPr/>
+                    <a:lstStyle/>
+                    <a:p>
+                      <a:r>
+                        <a:rPr sz="750" b="1">
+                          <a:solidFill>
+                            <a:srgbClr val="3DD6C6"/>
+                          </a:solidFill>
+                          <a:latin typeface="Apple SD Gothic Neo"/>
+                          <a:ea typeface="Apple SD Gothic Neo"/>
+                        </a:rPr>
+                        <a:t>가정</a:t>
+                      </a:r>
+                    </a:p>
+                  </a:txBody>
+                  <a:tcPr/>
+                </a:tc>
+                <a:tc>
+                  <a:txBody>
+                    <a:bodyPr/>
+                    <a:lstStyle/>
+                    <a:p>
+                      <a:r>
+                        <a:rPr sz="750" b="1">
+                          <a:solidFill>
+                            <a:srgbClr val="3DD6C6"/>
+                          </a:solidFill>
+                          <a:latin typeface="Apple SD Gothic Neo"/>
+                          <a:ea typeface="Apple SD Gothic Neo"/>
+                        </a:rPr>
+                        <a:t>설계 의도</a:t>
+                      </a:r>
+                    </a:p>
+                  </a:txBody>
+                  <a:tcPr/>
+                </a:tc>
+              </a:tr>
+              <a:tr h="201168">
+                <a:tc>
+                  <a:txBody>
+                    <a:bodyPr/>
+                    <a:lstStyle/>
+                    <a:p>
+                      <a:r>
+                        <a:rPr sz="750" b="1">
+                          <a:solidFill>
+                            <a:srgbClr val="ECF1F7"/>
+                          </a:solidFill>
+                          <a:latin typeface="Apple SD Gothic Neo"/>
+                          <a:ea typeface="Apple SD Gothic Neo"/>
+                        </a:rPr>
+                        <a:t>RUL = H − D</a:t>
+                      </a:r>
+                    </a:p>
+                  </a:txBody>
+                  <a:tcPr/>
+                </a:tc>
+                <a:tc>
+                  <a:txBody>
+                    <a:bodyPr/>
+                    <a:lstStyle/>
+                    <a:p>
+                      <a:r>
+                        <a:rPr sz="750" b="0">
+                          <a:solidFill>
+                            <a:srgbClr val="A0ADBC"/>
+                          </a:solidFill>
+                          <a:latin typeface="Apple SD Gothic Neo"/>
+                          <a:ea typeface="Apple SD Gothic Neo"/>
+                        </a:rPr>
+                        <a:t>건강−손상</a:t>
+                      </a:r>
+                    </a:p>
+                  </a:txBody>
+                  <a:tcPr/>
+                </a:tc>
+                <a:tc>
+                  <a:txBody>
+                    <a:bodyPr/>
+                    <a:lstStyle/>
+                    <a:p>
+                      <a:r>
+                        <a:rPr sz="750" b="0">
+                          <a:solidFill>
+                            <a:srgbClr val="A0ADBC"/>
+                          </a:solidFill>
+                          <a:latin typeface="Apple SD Gothic Neo"/>
+                          <a:ea typeface="Apple SD Gothic Neo"/>
+                        </a:rPr>
+                        <a:t>분해 가정 (disentangled)</a:t>
+                      </a:r>
+                    </a:p>
+                  </a:txBody>
+                  <a:tcPr/>
+                </a:tc>
+              </a:tr>
+              <a:tr h="201168">
+                <a:tc>
+                  <a:txBody>
+                    <a:bodyPr/>
+                    <a:lstStyle/>
+                    <a:p>
+                      <a:r>
+                        <a:rPr sz="750" b="1">
+                          <a:solidFill>
+                            <a:srgbClr val="ECF1F7"/>
+                          </a:solidFill>
+                          <a:latin typeface="Apple SD Gothic Neo"/>
+                          <a:ea typeface="Apple SD Gothic Neo"/>
+                        </a:rPr>
+                        <a:t>Isotonic</a:t>
+                      </a:r>
+                    </a:p>
+                  </a:txBody>
+                  <a:tcPr/>
+                </a:tc>
+                <a:tc>
+                  <a:txBody>
+                    <a:bodyPr/>
+                    <a:lstStyle/>
+                    <a:p>
+                      <a:r>
+                        <a:rPr sz="750" b="0">
+                          <a:solidFill>
+                            <a:srgbClr val="A0ADBC"/>
+                          </a:solidFill>
+                          <a:latin typeface="Apple SD Gothic Neo"/>
+                          <a:ea typeface="Apple SD Gothic Neo"/>
+                        </a:rPr>
+                        <a:t>cycle↑→RUL↓</a:t>
+                      </a:r>
+                    </a:p>
+                  </a:txBody>
+                  <a:tcPr/>
+                </a:tc>
+                <a:tc>
+                  <a:txBody>
+                    <a:bodyPr/>
+                    <a:lstStyle/>
+                    <a:p>
+                      <a:r>
+                        <a:rPr sz="750" b="0">
+                          <a:solidFill>
+                            <a:srgbClr val="A0ADBC"/>
+                          </a:solidFill>
+                          <a:latin typeface="Apple SD Gothic Neo"/>
+                          <a:ea typeface="Apple SD Gothic Neo"/>
+                        </a:rPr>
+                        <a:t>엔진별 시간 단조 후처리</a:t>
+                      </a:r>
+                    </a:p>
+                  </a:txBody>
+                  <a:tcPr/>
+                </a:tc>
+              </a:tr>
+              <a:tr h="201168">
+                <a:tc>
+                  <a:txBody>
+                    <a:bodyPr/>
+                    <a:lstStyle/>
+                    <a:p>
+                      <a:r>
+                        <a:rPr sz="750" b="1">
+                          <a:solidFill>
+                            <a:srgbClr val="ECF1F7"/>
+                          </a:solidFill>
+                          <a:latin typeface="Apple SD Gothic Neo"/>
+                          <a:ea typeface="Apple SD Gothic Neo"/>
+                        </a:rPr>
+                        <a:t>L_RUL</a:t>
+                      </a:r>
+                    </a:p>
+                  </a:txBody>
+                  <a:tcPr/>
+                </a:tc>
+                <a:tc>
+                  <a:txBody>
+                    <a:bodyPr/>
+                    <a:lstStyle/>
+                    <a:p>
+                      <a:r>
+                        <a:rPr sz="750" b="0">
                           <a:solidFill>
                             <a:srgbClr val="A0ADBC"/>
                           </a:solidFill>
@@ -4685,35 +5067,35 @@
                     <a:lstStyle/>
                     <a:p>
                       <a:r>
-                        <a:rPr sz="800" b="0">
+                        <a:rPr sz="750" b="0">
                           <a:solidFill>
                             <a:srgbClr val="A0ADBC"/>
                           </a:solidFill>
                           <a:latin typeface="Apple SD Gothic Neo"/>
                           <a:ea typeface="Apple SD Gothic Neo"/>
                         </a:rPr>
-                        <a:t>d_model 투영</a:t>
+                        <a:t>MSE · 라벨 fit (주 loss)</a:t>
                       </a:r>
                     </a:p>
                   </a:txBody>
                   <a:tcPr/>
                 </a:tc>
               </a:tr>
-              <a:tr h="219456">
+              <a:tr h="201168">
                 <a:tc>
                   <a:txBody>
                     <a:bodyPr/>
                     <a:lstStyle/>
                     <a:p>
                       <a:r>
-                        <a:rPr sz="800" b="1">
+                        <a:rPr sz="750" b="1">
                           <a:solidFill>
                             <a:srgbClr val="ECF1F7"/>
                           </a:solidFill>
                           <a:latin typeface="Apple SD Gothic Neo"/>
                           <a:ea typeface="Apple SD Gothic Neo"/>
                         </a:rPr>
-                        <a:t>Transformer×2</a:t>
+                        <a:t>L_physics</a:t>
                       </a:r>
                     </a:p>
                   </a:txBody>
@@ -4725,14 +5107,14 @@
                     <a:lstStyle/>
                     <a:p>
                       <a:r>
-                        <a:rPr sz="800" b="0">
+                        <a:rPr sz="750" b="0">
                           <a:solidFill>
                             <a:srgbClr val="A0ADBC"/>
                           </a:solidFill>
                           <a:latin typeface="Apple SD Gothic Neo"/>
                           <a:ea typeface="Apple SD Gothic Neo"/>
                         </a:rPr>
-                        <a:t>열화 시간 누적</a:t>
+                        <a:t>TRA Jacobian soft</a:t>
                       </a:r>
                     </a:p>
                   </a:txBody>
@@ -4744,73 +5126,14 @@
                     <a:lstStyle/>
                     <a:p>
                       <a:r>
-                        <a:rPr sz="800" b="0">
+                        <a:rPr sz="750" b="0">
                           <a:solidFill>
                             <a:srgbClr val="A0ADBC"/>
                           </a:solidFill>
                           <a:latin typeface="Apple SD Gothic Neo"/>
                           <a:ea typeface="Apple SD Gothic Neo"/>
                         </a:rPr>
-                        <a:t>MHA 시계열 의존</a:t>
-                      </a:r>
-                    </a:p>
-                  </a:txBody>
-                  <a:tcPr/>
-                </a:tc>
-              </a:tr>
-              <a:tr h="219456">
-                <a:tc>
-                  <a:txBody>
-                    <a:bodyPr/>
-                    <a:lstStyle/>
-                    <a:p>
-                      <a:r>
-                        <a:rPr sz="800" b="1">
-                          <a:solidFill>
-                            <a:srgbClr val="ECF1F7"/>
-                          </a:solidFill>
-                          <a:latin typeface="Apple SD Gothic Neo"/>
-                          <a:ea typeface="Apple SD Gothic Neo"/>
-                        </a:rPr>
-                        <a:t>Health Head → H</a:t>
-                      </a:r>
-                    </a:p>
-                  </a:txBody>
-                  <a:tcPr/>
-                </a:tc>
-                <a:tc>
-                  <a:txBody>
-                    <a:bodyPr/>
-                    <a:lstStyle/>
-                    <a:p>
-                      <a:r>
-                        <a:rPr sz="800" b="0">
-                          <a:solidFill>
-                            <a:srgbClr val="A0ADBC"/>
-                          </a:solidFill>
-                          <a:latin typeface="Apple SD Gothic Neo"/>
-                          <a:ea typeface="Apple SD Gothic Neo"/>
-                        </a:rPr>
-                        <a:t>H &gt; 0</a:t>
-                      </a:r>
-                    </a:p>
-                  </a:txBody>
-                  <a:tcPr/>
-                </a:tc>
-                <a:tc>
-                  <a:txBody>
-                    <a:bodyPr/>
-                    <a:lstStyle/>
-                    <a:p>
-                      <a:r>
-                        <a:rPr sz="800" b="0">
-                          <a:solidFill>
-                            <a:srgbClr val="A0ADBC"/>
-                          </a:solidFill>
-                          <a:latin typeface="Apple SD Gothic Neo"/>
-                          <a:ea typeface="Apple SD Gothic Neo"/>
-                        </a:rPr>
-                        <a:t>softplus 잠재 건강</a:t>
+                        <a:t>λ·L_phys — **보조** (구조와 중복)</a:t>
                       </a:r>
                     </a:p>
                   </a:txBody>
@@ -4821,446 +5144,6 @@
           </a:graphicData>
         </a:graphic>
       </p:graphicFrame>
-      <p:graphicFrame>
-        <p:nvGraphicFramePr>
-          <p:cNvPr id="13" name="Table 12"/>
-          <p:cNvGraphicFramePr>
-            <a:graphicFrameLocks noGrp="1"/>
-          </p:cNvGraphicFramePr>
-          <p:nvPr/>
-        </p:nvGraphicFramePr>
-        <p:xfrm>
-          <a:off x="6172200" y="3456432"/>
-          <a:ext cx="5623560" cy="1536192"/>
-        </p:xfrm>
-        <a:graphic>
-          <a:graphicData uri="http://schemas.openxmlformats.org/drawingml/2006/table">
-            <a:tbl>
-              <a:tblPr firstRow="1" bandRow="1">
-                <a:tableStyleId>{5C22544A-7EE6-4342-B048-85BDC9FD1C3A}</a:tableStyleId>
-              </a:tblPr>
-              <a:tblGrid>
-                <a:gridCol w="1234440"/>
-                <a:gridCol w="1691640"/>
-                <a:gridCol w="2697480"/>
-              </a:tblGrid>
-              <a:tr h="219456">
-                <a:tc>
-                  <a:txBody>
-                    <a:bodyPr/>
-                    <a:lstStyle/>
-                    <a:p>
-                      <a:r>
-                        <a:rPr sz="800" b="1">
-                          <a:solidFill>
-                            <a:srgbClr val="3DD6C6"/>
-                          </a:solidFill>
-                          <a:latin typeface="Apple SD Gothic Neo"/>
-                          <a:ea typeface="Apple SD Gothic Neo"/>
-                        </a:rPr>
-                        <a:t>구성요소</a:t>
-                      </a:r>
-                    </a:p>
-                  </a:txBody>
-                  <a:tcPr/>
-                </a:tc>
-                <a:tc>
-                  <a:txBody>
-                    <a:bodyPr/>
-                    <a:lstStyle/>
-                    <a:p>
-                      <a:r>
-                        <a:rPr sz="800" b="1">
-                          <a:solidFill>
-                            <a:srgbClr val="3DD6C6"/>
-                          </a:solidFill>
-                          <a:latin typeface="Apple SD Gothic Neo"/>
-                          <a:ea typeface="Apple SD Gothic Neo"/>
-                        </a:rPr>
-                        <a:t>가정</a:t>
-                      </a:r>
-                    </a:p>
-                  </a:txBody>
-                  <a:tcPr/>
-                </a:tc>
-                <a:tc>
-                  <a:txBody>
-                    <a:bodyPr/>
-                    <a:lstStyle/>
-                    <a:p>
-                      <a:r>
-                        <a:rPr sz="800" b="1">
-                          <a:solidFill>
-                            <a:srgbClr val="3DD6C6"/>
-                          </a:solidFill>
-                          <a:latin typeface="Apple SD Gothic Neo"/>
-                          <a:ea typeface="Apple SD Gothic Neo"/>
-                        </a:rPr>
-                        <a:t>설계 의도</a:t>
-                      </a:r>
-                    </a:p>
-                  </a:txBody>
-                  <a:tcPr/>
-                </a:tc>
-              </a:tr>
-              <a:tr h="219456">
-                <a:tc>
-                  <a:txBody>
-                    <a:bodyPr/>
-                    <a:lstStyle/>
-                    <a:p>
-                      <a:r>
-                        <a:rPr sz="800" b="1">
-                          <a:solidFill>
-                            <a:srgbClr val="ECF1F7"/>
-                          </a:solidFill>
-                          <a:latin typeface="Apple SD Gothic Neo"/>
-                          <a:ea typeface="Apple SD Gothic Neo"/>
-                        </a:rPr>
-                        <a:t>Load Extract</a:t>
-                      </a:r>
-                    </a:p>
-                  </a:txBody>
-                  <a:tcPr/>
-                </a:tc>
-                <a:tc>
-                  <a:txBody>
-                    <a:bodyPr/>
-                    <a:lstStyle/>
-                    <a:p>
-                      <a:r>
-                        <a:rPr sz="800" b="0">
-                          <a:solidFill>
-                            <a:srgbClr val="A0ADBC"/>
-                          </a:solidFill>
-                          <a:latin typeface="Apple SD Gothic Neo"/>
-                          <a:ea typeface="Apple SD Gothic Neo"/>
-                        </a:rPr>
-                        <a:t>손상=운용 함수</a:t>
-                      </a:r>
-                    </a:p>
-                  </a:txBody>
-                  <a:tcPr/>
-                </a:tc>
-                <a:tc>
-                  <a:txBody>
-                    <a:bodyPr/>
-                    <a:lstStyle/>
-                    <a:p>
-                      <a:r>
-                        <a:rPr sz="800" b="0">
-                          <a:solidFill>
-                            <a:srgbClr val="A0ADBC"/>
-                          </a:solidFill>
-                          <a:latin typeface="Apple SD Gothic Neo"/>
-                          <a:ea typeface="Apple SD Gothic Neo"/>
-                        </a:rPr>
-                        <a:t>TRA,φ,T30,cycle</a:t>
-                      </a:r>
-                    </a:p>
-                  </a:txBody>
-                  <a:tcPr/>
-                </a:tc>
-              </a:tr>
-              <a:tr h="219456">
-                <a:tc>
-                  <a:txBody>
-                    <a:bodyPr/>
-                    <a:lstStyle/>
-                    <a:p>
-                      <a:r>
-                        <a:rPr sz="800" b="1">
-                          <a:solidFill>
-                            <a:srgbClr val="ECF1F7"/>
-                          </a:solidFill>
-                          <a:latin typeface="Apple SD Gothic Neo"/>
-                          <a:ea typeface="Apple SD Gothic Neo"/>
-                        </a:rPr>
-                        <a:t>mono ∥ other</a:t>
-                      </a:r>
-                    </a:p>
-                  </a:txBody>
-                  <a:tcPr/>
-                </a:tc>
-                <a:tc>
-                  <a:txBody>
-                    <a:bodyPr/>
-                    <a:lstStyle/>
-                    <a:p>
-                      <a:r>
-                        <a:rPr sz="800" b="0">
-                          <a:solidFill>
-                            <a:srgbClr val="A0ADBC"/>
-                          </a:solidFill>
-                          <a:latin typeface="Apple SD Gothic Neo"/>
-                          <a:ea typeface="Apple SD Gothic Neo"/>
-                        </a:rPr>
-                        <a:t>TRA↑→손상↑</a:t>
-                      </a:r>
-                    </a:p>
-                  </a:txBody>
-                  <a:tcPr/>
-                </a:tc>
-                <a:tc>
-                  <a:txBody>
-                    <a:bodyPr/>
-                    <a:lstStyle/>
-                    <a:p>
-                      <a:r>
-                        <a:rPr sz="800" b="0">
-                          <a:solidFill>
-                            <a:srgbClr val="A0ADBC"/>
-                          </a:solidFill>
-                          <a:latin typeface="Apple SD Gothic Neo"/>
-                          <a:ea typeface="Apple SD Gothic Neo"/>
-                        </a:rPr>
-                        <a:t>단조 hard + MLP 보정</a:t>
-                      </a:r>
-                    </a:p>
-                  </a:txBody>
-                  <a:tcPr/>
-                </a:tc>
-              </a:tr>
-              <a:tr h="219456">
-                <a:tc>
-                  <a:txBody>
-                    <a:bodyPr/>
-                    <a:lstStyle/>
-                    <a:p>
-                      <a:r>
-                        <a:rPr sz="800" b="1">
-                          <a:solidFill>
-                            <a:srgbClr val="ECF1F7"/>
-                          </a:solidFill>
-                          <a:latin typeface="Apple SD Gothic Neo"/>
-                          <a:ea typeface="Apple SD Gothic Neo"/>
-                        </a:rPr>
-                        <a:t>D = mono+other</a:t>
-                      </a:r>
-                    </a:p>
-                  </a:txBody>
-                  <a:tcPr/>
-                </a:tc>
-                <a:tc>
-                  <a:txBody>
-                    <a:bodyPr/>
-                    <a:lstStyle/>
-                    <a:p>
-                      <a:r>
-                        <a:rPr sz="800" b="0">
-                          <a:solidFill>
-                            <a:srgbClr val="A0ADBC"/>
-                          </a:solidFill>
-                          <a:latin typeface="Apple SD Gothic Neo"/>
-                          <a:ea typeface="Apple SD Gothic Neo"/>
-                        </a:rPr>
-                        <a:t>누적 손상</a:t>
-                      </a:r>
-                    </a:p>
-                  </a:txBody>
-                  <a:tcPr/>
-                </a:tc>
-                <a:tc>
-                  <a:txBody>
-                    <a:bodyPr/>
-                    <a:lstStyle/>
-                    <a:p>
-                      <a:r>
-                        <a:rPr sz="800" b="0">
-                          <a:solidFill>
-                            <a:srgbClr val="A0ADBC"/>
-                          </a:solidFill>
-                          <a:latin typeface="Apple SD Gothic Neo"/>
-                          <a:ea typeface="Apple SD Gothic Neo"/>
-                        </a:rPr>
-                        <a:t>병렬 합산</a:t>
-                      </a:r>
-                    </a:p>
-                  </a:txBody>
-                  <a:tcPr/>
-                </a:tc>
-              </a:tr>
-              <a:tr h="219456">
-                <a:tc>
-                  <a:txBody>
-                    <a:bodyPr/>
-                    <a:lstStyle/>
-                    <a:p>
-                      <a:r>
-                        <a:rPr sz="800" b="1">
-                          <a:solidFill>
-                            <a:srgbClr val="ECF1F7"/>
-                          </a:solidFill>
-                          <a:latin typeface="Apple SD Gothic Neo"/>
-                          <a:ea typeface="Apple SD Gothic Neo"/>
-                        </a:rPr>
-                        <a:t>RUL = H−D</a:t>
-                      </a:r>
-                    </a:p>
-                  </a:txBody>
-                  <a:tcPr/>
-                </a:tc>
-                <a:tc>
-                  <a:txBody>
-                    <a:bodyPr/>
-                    <a:lstStyle/>
-                    <a:p>
-                      <a:r>
-                        <a:rPr sz="800" b="0">
-                          <a:solidFill>
-                            <a:srgbClr val="A0ADBC"/>
-                          </a:solidFill>
-                          <a:latin typeface="Apple SD Gothic Neo"/>
-                          <a:ea typeface="Apple SD Gothic Neo"/>
-                        </a:rPr>
-                        <a:t>수명=건강−손상</a:t>
-                      </a:r>
-                    </a:p>
-                  </a:txBody>
-                  <a:tcPr/>
-                </a:tc>
-                <a:tc>
-                  <a:txBody>
-                    <a:bodyPr/>
-                    <a:lstStyle/>
-                    <a:p>
-                      <a:r>
-                        <a:rPr sz="800" b="0">
-                          <a:solidFill>
-                            <a:srgbClr val="A0ADBC"/>
-                          </a:solidFill>
-                          <a:latin typeface="Apple SD Gothic Neo"/>
-                          <a:ea typeface="Apple SD Gothic Neo"/>
-                        </a:rPr>
-                        <a:t>분해 가정 고정</a:t>
-                      </a:r>
-                    </a:p>
-                  </a:txBody>
-                  <a:tcPr/>
-                </a:tc>
-              </a:tr>
-              <a:tr h="219456">
-                <a:tc>
-                  <a:txBody>
-                    <a:bodyPr/>
-                    <a:lstStyle/>
-                    <a:p>
-                      <a:r>
-                        <a:rPr sz="800" b="1">
-                          <a:solidFill>
-                            <a:srgbClr val="ECF1F7"/>
-                          </a:solidFill>
-                          <a:latin typeface="Apple SD Gothic Neo"/>
-                          <a:ea typeface="Apple SD Gothic Neo"/>
-                        </a:rPr>
-                        <a:t>Isotonic</a:t>
-                      </a:r>
-                    </a:p>
-                  </a:txBody>
-                  <a:tcPr/>
-                </a:tc>
-                <a:tc>
-                  <a:txBody>
-                    <a:bodyPr/>
-                    <a:lstStyle/>
-                    <a:p>
-                      <a:r>
-                        <a:rPr sz="800" b="0">
-                          <a:solidFill>
-                            <a:srgbClr val="A0ADBC"/>
-                          </a:solidFill>
-                          <a:latin typeface="Apple SD Gothic Neo"/>
-                          <a:ea typeface="Apple SD Gothic Neo"/>
-                        </a:rPr>
-                        <a:t>cycle↑→RUL↓</a:t>
-                      </a:r>
-                    </a:p>
-                  </a:txBody>
-                  <a:tcPr/>
-                </a:tc>
-                <a:tc>
-                  <a:txBody>
-                    <a:bodyPr/>
-                    <a:lstStyle/>
-                    <a:p>
-                      <a:r>
-                        <a:rPr sz="800" b="0">
-                          <a:solidFill>
-                            <a:srgbClr val="A0ADBC"/>
-                          </a:solidFill>
-                          <a:latin typeface="Apple SD Gothic Neo"/>
-                          <a:ea typeface="Apple SD Gothic Neo"/>
-                        </a:rPr>
-                        <a:t>엔진별 시간 단조</a:t>
-                      </a:r>
-                    </a:p>
-                  </a:txBody>
-                  <a:tcPr/>
-                </a:tc>
-              </a:tr>
-              <a:tr h="219456">
-                <a:tc>
-                  <a:txBody>
-                    <a:bodyPr/>
-                    <a:lstStyle/>
-                    <a:p>
-                      <a:r>
-                        <a:rPr sz="800" b="1">
-                          <a:solidFill>
-                            <a:srgbClr val="ECF1F7"/>
-                          </a:solidFill>
-                          <a:latin typeface="Apple SD Gothic Neo"/>
-                          <a:ea typeface="Apple SD Gothic Neo"/>
-                        </a:rPr>
-                        <a:t>Loss</a:t>
-                      </a:r>
-                    </a:p>
-                  </a:txBody>
-                  <a:tcPr/>
-                </a:tc>
-                <a:tc>
-                  <a:txBody>
-                    <a:bodyPr/>
-                    <a:lstStyle/>
-                    <a:p>
-                      <a:r>
-                        <a:rPr sz="800" b="0">
-                          <a:solidFill>
-                            <a:srgbClr val="A0ADBC"/>
-                          </a:solidFill>
-                          <a:latin typeface="Apple SD Gothic Neo"/>
-                          <a:ea typeface="Apple SD Gothic Neo"/>
-                        </a:rPr>
-                        <a:t>—</a:t>
-                      </a:r>
-                    </a:p>
-                  </a:txBody>
-                  <a:tcPr/>
-                </a:tc>
-                <a:tc>
-                  <a:txBody>
-                    <a:bodyPr/>
-                    <a:lstStyle/>
-                    <a:p>
-                      <a:r>
-                        <a:rPr sz="800" b="0">
-                          <a:solidFill>
-                            <a:srgbClr val="A0ADBC"/>
-                          </a:solidFill>
-                          <a:latin typeface="Apple SD Gothic Neo"/>
-                          <a:ea typeface="Apple SD Gothic Neo"/>
-                        </a:rPr>
-                        <a:t>L_RUL fit · 방향=구조</a:t>
-                      </a:r>
-                    </a:p>
-                  </a:txBody>
-                  <a:tcPr/>
-                </a:tc>
-              </a:tr>
-            </a:tbl>
-          </a:graphicData>
-        </a:graphic>
-      </p:graphicFrame>
       <p:sp>
         <p:nvSpPr>
           <p:cNvPr id="14" name="Rounded Rectangle 13"/>
@@ -5382,7 +5265,7 @@
                 <a:latin typeface="Apple SD Gothic Neo"/>
                 <a:ea typeface="Apple SD Gothic Neo"/>
               </a:rPr>
-              <a:t>가정을 블록 형태로 compile — fit은 L_RUL, 방향은 mask·head·iso</a:t>
+              <a:t>부하→수명 방향은 MonotoneLoadHead 항등식 — TRA mask + RUL=H−D</a:t>
             </a:r>
           </a:p>
           <a:p>
@@ -5399,7 +5282,7 @@
                 <a:latin typeface="Apple SD Gothic Neo"/>
                 <a:ea typeface="Apple SD Gothic Neo"/>
               </a:rPr>
-              <a:t>λ_tra=0에서도 방향 유지 (loss보다 구조가 prior)</a:t>
+              <a:t>∂RUL/∂TRA ≤ −softplus(w) &lt; 0 (구조상 위반 불가)</a:t>
             </a:r>
           </a:p>
         </p:txBody>
@@ -5539,7 +5422,7 @@
                 <a:latin typeface="Apple SD Gothic Neo"/>
                 <a:ea typeface="Apple SD Gothic Neo"/>
               </a:rPr>
-              <a:t>사례 3/4</a:t>
+              <a:t>사례 3/5</a:t>
             </a:r>
           </a:p>
         </p:txBody>
@@ -5575,7 +5458,7 @@
                 <a:latin typeface="Apple SD Gothic Neo"/>
                 <a:ea typeface="Apple SD Gothic Neo"/>
               </a:rPr>
-              <a:t>hard 구간에서 다른 모델과 비교하면</a:t>
+              <a:t>Physics loss vs 구조 prior — 무엇이 방향을 만드는가</a:t>
             </a:r>
           </a:p>
         </p:txBody>
@@ -5653,7 +5536,7 @@
                 <a:latin typeface="Apple SD Gothic Neo"/>
                 <a:ea typeface="Apple SD Gothic Neo"/>
               </a:rPr>
-              <a:t>CA-CSS v4 Case Appendix  ·  Kookmin Univ. IE Lab  ·  2026  ·  모델마다 학습 epoch 맞춘 공정 비교.</a:t>
+              <a:t>CA-CSS v4 Case Appendix  ·  Kookmin Univ. IE Lab  ·  2026  ·  PINN式 soft loss ≠ 여기서의 방향 메커니즘.</a:t>
             </a:r>
           </a:p>
         </p:txBody>
@@ -5689,7 +5572,7 @@
                 <a:latin typeface="Apple SD Gothic Neo"/>
                 <a:ea typeface="Apple SD Gothic Neo"/>
               </a:rPr>
-              <a:t>3 / 4</a:t>
+              <a:t>3 / 5</a:t>
             </a:r>
           </a:p>
         </p:txBody>
@@ -5702,8 +5585,8 @@
         </p:nvSpPr>
         <p:spPr>
           <a:xfrm>
-            <a:off x="384048" y="914400"/>
-            <a:ext cx="7699248" cy="3823748"/>
+            <a:off x="384048" y="960120"/>
+            <a:ext cx="11539728" cy="4942722"/>
           </a:xfrm>
           <a:prstGeom prst="roundRect">
             <a:avLst>
@@ -5743,7 +5626,7 @@
       </p:sp>
       <p:pic>
         <p:nvPicPr>
-          <p:cNvPr id="10" name="Picture 9" descr="fig_baseline_fair_hard.png"/>
+          <p:cNvPr id="10" name="Picture 9" descr="fig_physics_vs_structure.png"/>
           <p:cNvPicPr>
             <a:picLocks noChangeAspect="1"/>
           </p:cNvPicPr>
@@ -5757,8 +5640,8 @@
         </p:blipFill>
         <p:spPr>
           <a:xfrm>
-            <a:off x="438912" y="969264"/>
-            <a:ext cx="7589520" cy="3714020"/>
+            <a:off x="438912" y="1014984"/>
+            <a:ext cx="11430000" cy="4832994"/>
           </a:xfrm>
           <a:prstGeom prst="rect">
             <a:avLst/>
@@ -5773,7 +5656,918 @@
         </p:nvSpPr>
         <p:spPr>
           <a:xfrm>
-            <a:off x="384048" y="4756436"/>
+            <a:off x="384048" y="5921130"/>
+            <a:ext cx="11539728" cy="219456"/>
+          </a:xfrm>
+          <a:prstGeom prst="rect">
+            <a:avLst/>
+          </a:prstGeom>
+          <a:noFill/>
+        </p:spPr>
+        <p:txBody>
+          <a:bodyPr wrap="square">
+            <a:spAutoFit/>
+          </a:bodyPr>
+          <a:lstStyle/>
+          <a:p>
+            <a:pPr algn="l"/>
+            <a:r>
+              <a:rPr sz="900" b="0">
+                <a:solidFill>
+                  <a:srgbClr val="B8C4D0"/>
+                </a:solidFill>
+                <a:latin typeface="Apple SD Gothic Neo"/>
+                <a:ea typeface="Apple SD Gothic Neo"/>
+              </a:rPr>
+              <a:t>λ_tra 스윕: RMSE·adherence 모두 무반응 · no_physics +0.33</a:t>
+            </a:r>
+          </a:p>
+        </p:txBody>
+      </p:sp>
+      <p:sp>
+        <p:nvSpPr>
+          <p:cNvPr id="12" name="Rounded Rectangle 11"/>
+          <p:cNvSpPr/>
+          <p:nvPr/>
+        </p:nvSpPr>
+        <p:spPr>
+          <a:xfrm>
+            <a:off x="384048" y="3703320"/>
+            <a:ext cx="5486400" cy="1965960"/>
+          </a:xfrm>
+          <a:prstGeom prst="roundRect">
+            <a:avLst>
+              <a:gd name="adj" fmla="val 5000"/>
+            </a:avLst>
+          </a:prstGeom>
+          <a:solidFill>
+            <a:srgbClr val="141B24"/>
+          </a:solidFill>
+          <a:ln w="9525">
+            <a:solidFill>
+              <a:srgbClr val="2C3848"/>
+            </a:solidFill>
+          </a:ln>
+        </p:spPr>
+        <p:style>
+          <a:lnRef idx="1">
+            <a:schemeClr val="accent1"/>
+          </a:lnRef>
+          <a:fillRef idx="3">
+            <a:schemeClr val="accent1"/>
+          </a:fillRef>
+          <a:effectRef idx="2">
+            <a:schemeClr val="accent1"/>
+          </a:effectRef>
+          <a:fontRef idx="minor">
+            <a:schemeClr val="lt1"/>
+          </a:fontRef>
+        </p:style>
+        <p:txBody>
+          <a:bodyPr rtlCol="0" anchor="ctr"/>
+          <a:lstStyle/>
+          <a:p>
+            <a:pPr algn="ctr"/>
+          </a:p>
+        </p:txBody>
+      </p:sp>
+      <p:sp>
+        <p:nvSpPr>
+          <p:cNvPr id="13" name="Rectangle 12"/>
+          <p:cNvSpPr/>
+          <p:nvPr/>
+        </p:nvSpPr>
+        <p:spPr>
+          <a:xfrm>
+            <a:off x="384048" y="3703320"/>
+            <a:ext cx="54864" cy="1965960"/>
+          </a:xfrm>
+          <a:prstGeom prst="rect">
+            <a:avLst/>
+          </a:prstGeom>
+          <a:solidFill>
+            <a:srgbClr val="3DD6C6"/>
+          </a:solidFill>
+          <a:ln>
+            <a:noFill/>
+          </a:ln>
+        </p:spPr>
+        <p:style>
+          <a:lnRef idx="1">
+            <a:schemeClr val="accent1"/>
+          </a:lnRef>
+          <a:fillRef idx="3">
+            <a:schemeClr val="accent1"/>
+          </a:fillRef>
+          <a:effectRef idx="2">
+            <a:schemeClr val="accent1"/>
+          </a:effectRef>
+          <a:fontRef idx="minor">
+            <a:schemeClr val="lt1"/>
+          </a:fontRef>
+        </p:style>
+        <p:txBody>
+          <a:bodyPr rtlCol="0" anchor="ctr"/>
+          <a:lstStyle/>
+          <a:p>
+            <a:pPr algn="ctr"/>
+          </a:p>
+        </p:txBody>
+      </p:sp>
+      <p:sp>
+        <p:nvSpPr>
+          <p:cNvPr id="14" name="TextBox 13"/>
+          <p:cNvSpPr txBox="1"/>
+          <p:nvPr/>
+        </p:nvSpPr>
+        <p:spPr>
+          <a:xfrm>
+            <a:off x="585216" y="3831336"/>
+            <a:ext cx="5138928" cy="1764792"/>
+          </a:xfrm>
+          <a:prstGeom prst="rect">
+            <a:avLst/>
+          </a:prstGeom>
+          <a:noFill/>
+        </p:spPr>
+        <p:txBody>
+          <a:bodyPr wrap="square">
+            <a:spAutoFit/>
+          </a:bodyPr>
+          <a:lstStyle/>
+          <a:p>
+            <a:pPr algn="l"/>
+            <a:r>
+              <a:rPr sz="1200" b="1">
+                <a:solidFill>
+                  <a:srgbClr val="3DD6C6"/>
+                </a:solidFill>
+                <a:latin typeface="Apple SD Gothic Neo"/>
+                <a:ea typeface="Apple SD Gothic Neo"/>
+              </a:rPr>
+              <a:t>L = L_RUL + λ·L_physics</a:t>
+            </a:r>
+          </a:p>
+          <a:p>
+            <a:pPr algn="l">
+              <a:spcBef>
+                <a:spcPts val="300"/>
+              </a:spcBef>
+            </a:pPr>
+            <a:r>
+              <a:rPr sz="1100" b="0">
+                <a:solidFill>
+                  <a:srgbClr val="A0ADBC"/>
+                </a:solidFill>
+                <a:latin typeface="Apple SD Gothic Neo"/>
+                <a:ea typeface="Apple SD Gothic Neo"/>
+              </a:rPr>
+              <a:t>•  L_physics: TRA Jacobian·단조 hinge (soft constraint)</a:t>
+            </a:r>
+          </a:p>
+          <a:p>
+            <a:pPr algn="l">
+              <a:spcBef>
+                <a:spcPts val="300"/>
+              </a:spcBef>
+            </a:pPr>
+            <a:r>
+              <a:rPr sz="1100" b="0">
+                <a:solidFill>
+                  <a:srgbClr val="A0ADBC"/>
+                </a:solidFill>
+                <a:latin typeface="Apple SD Gothic Neo"/>
+                <a:ea typeface="Apple SD Gothic Neo"/>
+              </a:rPr>
+              <a:t>•  no_physics: RMSE +0.33 — fit 보조 역할</a:t>
+            </a:r>
+          </a:p>
+          <a:p>
+            <a:pPr algn="l">
+              <a:spcBef>
+                <a:spcPts val="300"/>
+              </a:spcBef>
+            </a:pPr>
+            <a:r>
+              <a:rPr sz="1100" b="0">
+                <a:solidFill>
+                  <a:srgbClr val="A0ADBC"/>
+                </a:solidFill>
+                <a:latin typeface="Apple SD Gothic Neo"/>
+                <a:ea typeface="Apple SD Gothic Neo"/>
+              </a:rPr>
+              <a:t>•  λ_tra 0 / 0.05 / 0.5: RMSE ±0.09 · adherence 100%</a:t>
+            </a:r>
+          </a:p>
+        </p:txBody>
+      </p:sp>
+      <p:sp>
+        <p:nvSpPr>
+          <p:cNvPr id="15" name="Rounded Rectangle 14"/>
+          <p:cNvSpPr/>
+          <p:nvPr/>
+        </p:nvSpPr>
+        <p:spPr>
+          <a:xfrm>
+            <a:off x="5989320" y="3703320"/>
+            <a:ext cx="5806440" cy="1965960"/>
+          </a:xfrm>
+          <a:prstGeom prst="roundRect">
+            <a:avLst>
+              <a:gd name="adj" fmla="val 5000"/>
+            </a:avLst>
+          </a:prstGeom>
+          <a:solidFill>
+            <a:srgbClr val="141B24"/>
+          </a:solidFill>
+          <a:ln w="9525">
+            <a:solidFill>
+              <a:srgbClr val="2C3848"/>
+            </a:solidFill>
+          </a:ln>
+        </p:spPr>
+        <p:style>
+          <a:lnRef idx="1">
+            <a:schemeClr val="accent1"/>
+          </a:lnRef>
+          <a:fillRef idx="3">
+            <a:schemeClr val="accent1"/>
+          </a:fillRef>
+          <a:effectRef idx="2">
+            <a:schemeClr val="accent1"/>
+          </a:effectRef>
+          <a:fontRef idx="minor">
+            <a:schemeClr val="lt1"/>
+          </a:fontRef>
+        </p:style>
+        <p:txBody>
+          <a:bodyPr rtlCol="0" anchor="ctr"/>
+          <a:lstStyle/>
+          <a:p>
+            <a:pPr algn="ctr"/>
+          </a:p>
+        </p:txBody>
+      </p:sp>
+      <p:sp>
+        <p:nvSpPr>
+          <p:cNvPr id="16" name="Rectangle 15"/>
+          <p:cNvSpPr/>
+          <p:nvPr/>
+        </p:nvSpPr>
+        <p:spPr>
+          <a:xfrm>
+            <a:off x="5989320" y="3703320"/>
+            <a:ext cx="54864" cy="1965960"/>
+          </a:xfrm>
+          <a:prstGeom prst="rect">
+            <a:avLst/>
+          </a:prstGeom>
+          <a:solidFill>
+            <a:srgbClr val="E89A5C"/>
+          </a:solidFill>
+          <a:ln>
+            <a:noFill/>
+          </a:ln>
+        </p:spPr>
+        <p:style>
+          <a:lnRef idx="1">
+            <a:schemeClr val="accent1"/>
+          </a:lnRef>
+          <a:fillRef idx="3">
+            <a:schemeClr val="accent1"/>
+          </a:fillRef>
+          <a:effectRef idx="2">
+            <a:schemeClr val="accent1"/>
+          </a:effectRef>
+          <a:fontRef idx="minor">
+            <a:schemeClr val="lt1"/>
+          </a:fontRef>
+        </p:style>
+        <p:txBody>
+          <a:bodyPr rtlCol="0" anchor="ctr"/>
+          <a:lstStyle/>
+          <a:p>
+            <a:pPr algn="ctr"/>
+          </a:p>
+        </p:txBody>
+      </p:sp>
+      <p:sp>
+        <p:nvSpPr>
+          <p:cNvPr id="17" name="TextBox 16"/>
+          <p:cNvSpPr txBox="1"/>
+          <p:nvPr/>
+        </p:nvSpPr>
+        <p:spPr>
+          <a:xfrm>
+            <a:off x="6190488" y="3831336"/>
+            <a:ext cx="5458968" cy="1764792"/>
+          </a:xfrm>
+          <a:prstGeom prst="rect">
+            <a:avLst/>
+          </a:prstGeom>
+          <a:noFill/>
+        </p:spPr>
+        <p:txBody>
+          <a:bodyPr wrap="square">
+            <a:spAutoFit/>
+          </a:bodyPr>
+          <a:lstStyle/>
+          <a:p>
+            <a:pPr algn="l"/>
+            <a:r>
+              <a:rPr sz="1200" b="1">
+                <a:solidFill>
+                  <a:srgbClr val="E89A5C"/>
+                </a:solidFill>
+                <a:latin typeface="Apple SD Gothic Neo"/>
+                <a:ea typeface="Apple SD Gothic Neo"/>
+              </a:rPr>
+              <a:t>구조 ablation → 방향 인과</a:t>
+            </a:r>
+          </a:p>
+          <a:p>
+            <a:pPr algn="l">
+              <a:spcBef>
+                <a:spcPts val="300"/>
+              </a:spcBef>
+            </a:pPr>
+            <a:r>
+              <a:rPr sz="1100" b="0">
+                <a:solidFill>
+                  <a:srgbClr val="A0ADBC"/>
+                </a:solidFill>
+                <a:latin typeface="Apple SD Gothic Neo"/>
+                <a:ea typeface="Apple SD Gothic Neo"/>
+              </a:rPr>
+              <a:t>•  full: RMSE 3.88 · ΔRUL&lt;0 100%</a:t>
+            </a:r>
+          </a:p>
+          <a:p>
+            <a:pPr algn="l">
+              <a:spcBef>
+                <a:spcPts val="300"/>
+              </a:spcBef>
+            </a:pPr>
+            <a:r>
+              <a:rPr sz="1100" b="0">
+                <a:solidFill>
+                  <a:srgbClr val="A0ADBC"/>
+                </a:solidFill>
+                <a:latin typeface="Apple SD Gothic Neo"/>
+                <a:ea typeface="Apple SD Gothic Neo"/>
+              </a:rPr>
+              <a:t>•  free_load: RMSE 4.24 · adherence 0%</a:t>
+            </a:r>
+          </a:p>
+          <a:p>
+            <a:pPr algn="l">
+              <a:spcBef>
+                <a:spcPts val="300"/>
+              </a:spcBef>
+            </a:pPr>
+            <a:r>
+              <a:rPr sz="1100" b="0">
+                <a:solidFill>
+                  <a:srgbClr val="A0ADBC"/>
+                </a:solidFill>
+                <a:latin typeface="Apple SD Gothic Neo"/>
+                <a:ea typeface="Apple SD Gothic Neo"/>
+              </a:rPr>
+              <a:t>•  mono head 제거 = worst seed 6.1</a:t>
+            </a:r>
+          </a:p>
+          <a:p>
+            <a:pPr algn="l">
+              <a:spcBef>
+                <a:spcPts val="300"/>
+              </a:spcBef>
+            </a:pPr>
+            <a:r>
+              <a:rPr sz="1100" b="0">
+                <a:solidFill>
+                  <a:srgbClr val="A0ADBC"/>
+                </a:solidFill>
+                <a:latin typeface="Apple SD Gothic Neo"/>
+                <a:ea typeface="Apple SD Gothic Neo"/>
+              </a:rPr>
+              <a:t>•  레버 = MonotoneLoadHead, not λ_tra</a:t>
+            </a:r>
+          </a:p>
+        </p:txBody>
+      </p:sp>
+      <p:sp>
+        <p:nvSpPr>
+          <p:cNvPr id="18" name="Rounded Rectangle 17"/>
+          <p:cNvSpPr/>
+          <p:nvPr/>
+        </p:nvSpPr>
+        <p:spPr>
+          <a:xfrm>
+            <a:off x="365760" y="5833872"/>
+            <a:ext cx="11430000" cy="512064"/>
+          </a:xfrm>
+          <a:prstGeom prst="roundRect">
+            <a:avLst>
+              <a:gd name="adj" fmla="val 4000"/>
+            </a:avLst>
+          </a:prstGeom>
+          <a:solidFill>
+            <a:srgbClr val="243A42"/>
+          </a:solidFill>
+          <a:ln w="9525">
+            <a:solidFill>
+              <a:srgbClr val="2C3848"/>
+            </a:solidFill>
+          </a:ln>
+        </p:spPr>
+        <p:style>
+          <a:lnRef idx="1">
+            <a:schemeClr val="accent1"/>
+          </a:lnRef>
+          <a:fillRef idx="3">
+            <a:schemeClr val="accent1"/>
+          </a:fillRef>
+          <a:effectRef idx="2">
+            <a:schemeClr val="accent1"/>
+          </a:effectRef>
+          <a:fontRef idx="minor">
+            <a:schemeClr val="lt1"/>
+          </a:fontRef>
+        </p:style>
+        <p:txBody>
+          <a:bodyPr rtlCol="0" anchor="ctr"/>
+          <a:lstStyle/>
+          <a:p>
+            <a:pPr algn="ctr"/>
+          </a:p>
+        </p:txBody>
+      </p:sp>
+      <p:sp>
+        <p:nvSpPr>
+          <p:cNvPr id="19" name="Rectangle 18"/>
+          <p:cNvSpPr/>
+          <p:nvPr/>
+        </p:nvSpPr>
+        <p:spPr>
+          <a:xfrm>
+            <a:off x="365760" y="5833872"/>
+            <a:ext cx="64008" cy="512064"/>
+          </a:xfrm>
+          <a:prstGeom prst="rect">
+            <a:avLst/>
+          </a:prstGeom>
+          <a:solidFill>
+            <a:srgbClr val="3DD6C6"/>
+          </a:solidFill>
+          <a:ln>
+            <a:noFill/>
+          </a:ln>
+        </p:spPr>
+        <p:style>
+          <a:lnRef idx="1">
+            <a:schemeClr val="accent1"/>
+          </a:lnRef>
+          <a:fillRef idx="3">
+            <a:schemeClr val="accent1"/>
+          </a:fillRef>
+          <a:effectRef idx="2">
+            <a:schemeClr val="accent1"/>
+          </a:effectRef>
+          <a:fontRef idx="minor">
+            <a:schemeClr val="lt1"/>
+          </a:fontRef>
+        </p:style>
+        <p:txBody>
+          <a:bodyPr rtlCol="0" anchor="ctr"/>
+          <a:lstStyle/>
+          <a:p>
+            <a:pPr algn="ctr"/>
+          </a:p>
+        </p:txBody>
+      </p:sp>
+      <p:sp>
+        <p:nvSpPr>
+          <p:cNvPr id="20" name="TextBox 19"/>
+          <p:cNvSpPr txBox="1"/>
+          <p:nvPr/>
+        </p:nvSpPr>
+        <p:spPr>
+          <a:xfrm>
+            <a:off x="566928" y="5879592"/>
+            <a:ext cx="11064240" cy="438912"/>
+          </a:xfrm>
+          <a:prstGeom prst="rect">
+            <a:avLst/>
+          </a:prstGeom>
+          <a:noFill/>
+        </p:spPr>
+        <p:txBody>
+          <a:bodyPr wrap="square">
+            <a:spAutoFit/>
+          </a:bodyPr>
+          <a:lstStyle/>
+          <a:p>
+            <a:pPr algn="l"/>
+            <a:r>
+              <a:rPr sz="1200" b="1">
+                <a:solidFill>
+                  <a:srgbClr val="ECF1F7"/>
+                </a:solidFill>
+                <a:latin typeface="Apple SD Gothic Neo"/>
+                <a:ea typeface="Apple SD Gothic Neo"/>
+              </a:rPr>
+              <a:t>physics loss는 fit 보조 — counterfactual 방향은 구조 prior</a:t>
+            </a:r>
+          </a:p>
+          <a:p>
+            <a:pPr algn="l">
+              <a:spcBef>
+                <a:spcPts val="100"/>
+              </a:spcBef>
+            </a:pPr>
+            <a:r>
+              <a:rPr sz="1000" b="0">
+                <a:solidFill>
+                  <a:srgbClr val="B8C4D0"/>
+                </a:solidFill>
+                <a:latin typeface="Apple SD Gothic Neo"/>
+                <a:ea typeface="Apple SD Gothic Neo"/>
+              </a:rPr>
+              <a:t>‘물리 법칙 준수’ ✗ · ‘도메인 prior + OOD RMSE’ ✓</a:t>
+            </a:r>
+          </a:p>
+        </p:txBody>
+      </p:sp>
+    </p:spTree>
+  </p:cSld>
+  <p:clrMapOvr>
+    <a:masterClrMapping/>
+  </p:clrMapOvr>
+</p:sld>
+</file>
+
+<file path=ppt/slides/slide4.xml><?xml version="1.0" encoding="utf-8"?>
+<p:sld xmlns:a="http://schemas.openxmlformats.org/drawingml/2006/main" xmlns:p="http://schemas.openxmlformats.org/presentationml/2006/main" xmlns:r="http://schemas.openxmlformats.org/officeDocument/2006/relationships">
+  <p:cSld>
+    <p:spTree>
+      <p:nvGrpSpPr>
+        <p:cNvPr id="1" name=""/>
+        <p:cNvGrpSpPr/>
+        <p:nvPr/>
+      </p:nvGrpSpPr>
+      <p:grpSpPr/>
+      <p:sp>
+        <p:nvSpPr>
+          <p:cNvPr id="2" name="Rectangle 1"/>
+          <p:cNvSpPr/>
+          <p:nvPr/>
+        </p:nvSpPr>
+        <p:spPr>
+          <a:xfrm>
+            <a:off x="0" y="0"/>
+            <a:ext cx="12191695" cy="6858000"/>
+          </a:xfrm>
+          <a:prstGeom prst="rect">
+            <a:avLst/>
+          </a:prstGeom>
+          <a:solidFill>
+            <a:srgbClr val="0B1016"/>
+          </a:solidFill>
+          <a:ln>
+            <a:noFill/>
+          </a:ln>
+        </p:spPr>
+        <p:style>
+          <a:lnRef idx="1">
+            <a:schemeClr val="accent1"/>
+          </a:lnRef>
+          <a:fillRef idx="3">
+            <a:schemeClr val="accent1"/>
+          </a:fillRef>
+          <a:effectRef idx="2">
+            <a:schemeClr val="accent1"/>
+          </a:effectRef>
+          <a:fontRef idx="minor">
+            <a:schemeClr val="lt1"/>
+          </a:fontRef>
+        </p:style>
+        <p:txBody>
+          <a:bodyPr rtlCol="0" anchor="ctr"/>
+          <a:lstStyle/>
+          <a:p>
+            <a:pPr algn="ctr"/>
+          </a:p>
+        </p:txBody>
+      </p:sp>
+      <p:sp>
+        <p:nvSpPr>
+          <p:cNvPr id="3" name="Rectangle 2"/>
+          <p:cNvSpPr/>
+          <p:nvPr/>
+        </p:nvSpPr>
+        <p:spPr>
+          <a:xfrm>
+            <a:off x="0" y="0"/>
+            <a:ext cx="73152" cy="6858000"/>
+          </a:xfrm>
+          <a:prstGeom prst="rect">
+            <a:avLst/>
+          </a:prstGeom>
+          <a:solidFill>
+            <a:srgbClr val="3DD6C6"/>
+          </a:solidFill>
+          <a:ln>
+            <a:noFill/>
+          </a:ln>
+        </p:spPr>
+        <p:style>
+          <a:lnRef idx="1">
+            <a:schemeClr val="accent1"/>
+          </a:lnRef>
+          <a:fillRef idx="3">
+            <a:schemeClr val="accent1"/>
+          </a:fillRef>
+          <a:effectRef idx="2">
+            <a:schemeClr val="accent1"/>
+          </a:effectRef>
+          <a:fontRef idx="minor">
+            <a:schemeClr val="lt1"/>
+          </a:fontRef>
+        </p:style>
+        <p:txBody>
+          <a:bodyPr rtlCol="0" anchor="ctr"/>
+          <a:lstStyle/>
+          <a:p>
+            <a:pPr algn="ctr"/>
+          </a:p>
+        </p:txBody>
+      </p:sp>
+      <p:sp>
+        <p:nvSpPr>
+          <p:cNvPr id="4" name="TextBox 3"/>
+          <p:cNvSpPr txBox="1"/>
+          <p:nvPr/>
+        </p:nvSpPr>
+        <p:spPr>
+          <a:xfrm>
+            <a:off x="384048" y="237744"/>
+            <a:ext cx="9601200" cy="274320"/>
+          </a:xfrm>
+          <a:prstGeom prst="rect">
+            <a:avLst/>
+          </a:prstGeom>
+          <a:noFill/>
+        </p:spPr>
+        <p:txBody>
+          <a:bodyPr wrap="square">
+            <a:spAutoFit/>
+          </a:bodyPr>
+          <a:lstStyle/>
+          <a:p>
+            <a:pPr algn="l"/>
+            <a:r>
+              <a:rPr sz="1100" b="1">
+                <a:solidFill>
+                  <a:srgbClr val="3DD6C6"/>
+                </a:solidFill>
+                <a:latin typeface="Apple SD Gothic Neo"/>
+                <a:ea typeface="Apple SD Gothic Neo"/>
+              </a:rPr>
+              <a:t>사례 4/5</a:t>
+            </a:r>
+          </a:p>
+        </p:txBody>
+      </p:sp>
+      <p:sp>
+        <p:nvSpPr>
+          <p:cNvPr id="5" name="TextBox 4"/>
+          <p:cNvSpPr txBox="1"/>
+          <p:nvPr/>
+        </p:nvSpPr>
+        <p:spPr>
+          <a:xfrm>
+            <a:off x="384048" y="475488"/>
+            <a:ext cx="10972800" cy="457200"/>
+          </a:xfrm>
+          <a:prstGeom prst="rect">
+            <a:avLst/>
+          </a:prstGeom>
+          <a:noFill/>
+        </p:spPr>
+        <p:txBody>
+          <a:bodyPr wrap="square">
+            <a:spAutoFit/>
+          </a:bodyPr>
+          <a:lstStyle/>
+          <a:p>
+            <a:pPr algn="l"/>
+            <a:r>
+              <a:rPr sz="2400" b="1">
+                <a:solidFill>
+                  <a:srgbClr val="ECF1F7"/>
+                </a:solidFill>
+                <a:latin typeface="Apple SD Gothic Neo"/>
+                <a:ea typeface="Apple SD Gothic Neo"/>
+              </a:rPr>
+              <a:t>hard 구간에서 다른 모델과 비교하면</a:t>
+            </a:r>
+          </a:p>
+        </p:txBody>
+      </p:sp>
+      <p:sp>
+        <p:nvSpPr>
+          <p:cNvPr id="6" name="Rectangle 5"/>
+          <p:cNvSpPr/>
+          <p:nvPr/>
+        </p:nvSpPr>
+        <p:spPr>
+          <a:xfrm>
+            <a:off x="384048" y="987552"/>
+            <a:ext cx="11430000" cy="12700"/>
+          </a:xfrm>
+          <a:prstGeom prst="rect">
+            <a:avLst/>
+          </a:prstGeom>
+          <a:solidFill>
+            <a:srgbClr val="2C3848"/>
+          </a:solidFill>
+          <a:ln>
+            <a:noFill/>
+          </a:ln>
+        </p:spPr>
+        <p:style>
+          <a:lnRef idx="1">
+            <a:schemeClr val="accent1"/>
+          </a:lnRef>
+          <a:fillRef idx="3">
+            <a:schemeClr val="accent1"/>
+          </a:fillRef>
+          <a:effectRef idx="2">
+            <a:schemeClr val="accent1"/>
+          </a:effectRef>
+          <a:fontRef idx="minor">
+            <a:schemeClr val="lt1"/>
+          </a:fontRef>
+        </p:style>
+        <p:txBody>
+          <a:bodyPr rtlCol="0" anchor="ctr"/>
+          <a:lstStyle/>
+          <a:p>
+            <a:pPr algn="ctr"/>
+          </a:p>
+        </p:txBody>
+      </p:sp>
+      <p:sp>
+        <p:nvSpPr>
+          <p:cNvPr id="7" name="TextBox 6"/>
+          <p:cNvSpPr txBox="1"/>
+          <p:nvPr/>
+        </p:nvSpPr>
+        <p:spPr>
+          <a:xfrm>
+            <a:off x="457200" y="6473952"/>
+            <a:ext cx="9144000" cy="292608"/>
+          </a:xfrm>
+          <a:prstGeom prst="rect">
+            <a:avLst/>
+          </a:prstGeom>
+          <a:noFill/>
+        </p:spPr>
+        <p:txBody>
+          <a:bodyPr wrap="none">
+            <a:spAutoFit/>
+          </a:bodyPr>
+          <a:lstStyle/>
+          <a:p>
+            <a:r>
+              <a:rPr sz="900" b="0">
+                <a:solidFill>
+                  <a:srgbClr val="6E7C8C"/>
+                </a:solidFill>
+                <a:latin typeface="Apple SD Gothic Neo"/>
+                <a:ea typeface="Apple SD Gothic Neo"/>
+              </a:rPr>
+              <a:t>CA-CSS v4 Case Appendix  ·  Kookmin Univ. IE Lab  ·  2026  ·  모델마다 학습 epoch 맞춘 공정 비교.</a:t>
+            </a:r>
+          </a:p>
+        </p:txBody>
+      </p:sp>
+      <p:sp>
+        <p:nvSpPr>
+          <p:cNvPr id="8" name="TextBox 7"/>
+          <p:cNvSpPr txBox="1"/>
+          <p:nvPr/>
+        </p:nvSpPr>
+        <p:spPr>
+          <a:xfrm>
+            <a:off x="10607040" y="6473952"/>
+            <a:ext cx="1280160" cy="292608"/>
+          </a:xfrm>
+          <a:prstGeom prst="rect">
+            <a:avLst/>
+          </a:prstGeom>
+          <a:noFill/>
+        </p:spPr>
+        <p:txBody>
+          <a:bodyPr wrap="none">
+            <a:spAutoFit/>
+          </a:bodyPr>
+          <a:lstStyle/>
+          <a:p>
+            <a:pPr algn="r"/>
+            <a:r>
+              <a:rPr sz="900" b="0">
+                <a:solidFill>
+                  <a:srgbClr val="6E7C8C"/>
+                </a:solidFill>
+                <a:latin typeface="Apple SD Gothic Neo"/>
+                <a:ea typeface="Apple SD Gothic Neo"/>
+              </a:rPr>
+              <a:t>4 / 5</a:t>
+            </a:r>
+          </a:p>
+        </p:txBody>
+      </p:sp>
+      <p:sp>
+        <p:nvSpPr>
+          <p:cNvPr id="9" name="Rounded Rectangle 8"/>
+          <p:cNvSpPr/>
+          <p:nvPr/>
+        </p:nvSpPr>
+        <p:spPr>
+          <a:xfrm>
+            <a:off x="384048" y="914400"/>
+            <a:ext cx="7699248" cy="3778555"/>
+          </a:xfrm>
+          <a:prstGeom prst="roundRect">
+            <a:avLst>
+              <a:gd name="adj" fmla="val 4000"/>
+            </a:avLst>
+          </a:prstGeom>
+          <a:solidFill>
+            <a:srgbClr val="18212C"/>
+          </a:solidFill>
+          <a:ln w="9525">
+            <a:solidFill>
+              <a:srgbClr val="2C3848"/>
+            </a:solidFill>
+          </a:ln>
+        </p:spPr>
+        <p:style>
+          <a:lnRef idx="1">
+            <a:schemeClr val="accent1"/>
+          </a:lnRef>
+          <a:fillRef idx="3">
+            <a:schemeClr val="accent1"/>
+          </a:fillRef>
+          <a:effectRef idx="2">
+            <a:schemeClr val="accent1"/>
+          </a:effectRef>
+          <a:fontRef idx="minor">
+            <a:schemeClr val="lt1"/>
+          </a:fontRef>
+        </p:style>
+        <p:txBody>
+          <a:bodyPr rtlCol="0" anchor="ctr"/>
+          <a:lstStyle/>
+          <a:p>
+            <a:pPr algn="ctr"/>
+          </a:p>
+        </p:txBody>
+      </p:sp>
+      <p:pic>
+        <p:nvPicPr>
+          <p:cNvPr id="10" name="Picture 9" descr="fig_baseline_fair_hard.png"/>
+          <p:cNvPicPr>
+            <a:picLocks noChangeAspect="1"/>
+          </p:cNvPicPr>
+          <p:nvPr/>
+        </p:nvPicPr>
+        <p:blipFill>
+          <a:blip r:embed="rId2"/>
+          <a:stretch>
+            <a:fillRect/>
+          </a:stretch>
+        </p:blipFill>
+        <p:spPr>
+          <a:xfrm>
+            <a:off x="438912" y="969264"/>
+            <a:ext cx="7589520" cy="3668827"/>
+          </a:xfrm>
+          <a:prstGeom prst="rect">
+            <a:avLst/>
+          </a:prstGeom>
+        </p:spPr>
+      </p:pic>
+      <p:sp>
+        <p:nvSpPr>
+          <p:cNvPr id="11" name="TextBox 10"/>
+          <p:cNvSpPr txBox="1"/>
+          <p:nvPr/>
+        </p:nvSpPr>
+        <p:spPr>
+          <a:xfrm>
+            <a:off x="384048" y="4711243"/>
             <a:ext cx="7699248" cy="219456"/>
           </a:xfrm>
           <a:prstGeom prst="rect">
@@ -6379,7 +7173,7 @@
                 <a:latin typeface="Apple SD Gothic Neo"/>
                 <a:ea typeface="Apple SD Gothic Neo"/>
               </a:rPr>
-              <a:t>•  LSTM도 epoch 늘리면 4.8까지 올라옴</a:t>
+              <a:t>•  LSTM/Trans도 fair epoch면 4.8~5.0</a:t>
             </a:r>
           </a:p>
           <a:p>
@@ -6396,7 +7190,7 @@
                 <a:latin typeface="Apple SD Gothic Neo"/>
                 <a:ea typeface="Apple SD Gothic Neo"/>
               </a:rPr>
-              <a:t>•  그래도 v4가 3.4대 · 설명력 R² 0.97</a:t>
+              <a:t>•  v4+iso 3.43±0.73 · R² 0.97 (10-seed)</a:t>
             </a:r>
           </a:p>
           <a:p>
@@ -6413,7 +7207,7 @@
                 <a:latin typeface="Apple SD Gothic Neo"/>
                 <a:ea typeface="Apple SD Gothic Neo"/>
               </a:rPr>
-              <a:t>•  10번 반복 실험에서 TabPFN보다 유의하게 좋음</a:t>
+              <a:t>•  p=0.00017 vs TabPFN — hard만 차별화</a:t>
             </a:r>
           </a:p>
           <a:p>
@@ -6430,7 +7224,7 @@
                 <a:latin typeface="Apple SD Gothic Neo"/>
                 <a:ea typeface="Apple SD Gothic Neo"/>
               </a:rPr>
-              <a:t>•  외삽 구간에서 ‘부하 올리면 수명↓’ 100% 유지</a:t>
+              <a:t>•  C-MAPSS e120 ≈ Transformer (headline ✗)</a:t>
             </a:r>
           </a:p>
         </p:txBody>
@@ -6556,7 +7350,7 @@
                 <a:latin typeface="Apple SD Gothic Neo"/>
                 <a:ea typeface="Apple SD Gothic Neo"/>
               </a:rPr>
-              <a:t>공정하게 맞춰도 v4만 TabPFN·Transformer·LSTM을 한꺼번에 이긴다</a:t>
+              <a:t>결합 hard만 v4 유일 우위 — C-MAPSS 단일축은 수렴하면 비슷</a:t>
             </a:r>
           </a:p>
         </p:txBody>
@@ -6569,7 +7363,7 @@
 </p:sld>
 </file>
 
-<file path=ppt/slides/slide4.xml><?xml version="1.0" encoding="utf-8"?>
+<file path=ppt/slides/slide5.xml><?xml version="1.0" encoding="utf-8"?>
 <p:sld xmlns:a="http://schemas.openxmlformats.org/drawingml/2006/main" xmlns:p="http://schemas.openxmlformats.org/presentationml/2006/main" xmlns:r="http://schemas.openxmlformats.org/officeDocument/2006/relationships">
   <p:cSld>
     <p:spTree>
@@ -6696,7 +7490,7 @@
                 <a:latin typeface="Apple SD Gothic Neo"/>
                 <a:ea typeface="Apple SD Gothic Neo"/>
               </a:rPr>
-              <a:t>사례 4/4</a:t>
+              <a:t>사례 5/5</a:t>
             </a:r>
           </a:p>
         </p:txBody>
@@ -6846,7 +7640,7 @@
                 <a:latin typeface="Apple SD Gothic Neo"/>
                 <a:ea typeface="Apple SD Gothic Neo"/>
               </a:rPr>
-              <a:t>4 / 4</a:t>
+              <a:t>5 / 5</a:t>
             </a:r>
           </a:p>
         </p:txBody>
@@ -6989,7 +7783,7 @@
                 <a:latin typeface="Apple SD Gothic Neo"/>
                 <a:ea typeface="Apple SD Gothic Neo"/>
               </a:rPr>
-              <a:t>•  hard 구간 오차·R²가 baseline보다 낫다</a:t>
+              <a:t>•  hard extrap RMSE ↓ (10-seed, p=0.00017)</a:t>
             </a:r>
           </a:p>
           <a:p>
@@ -7006,7 +7800,7 @@
                 <a:latin typeface="Apple SD Gothic Neo"/>
                 <a:ea typeface="Apple SD Gothic Neo"/>
               </a:rPr>
-              <a:t>•  설계한 부하 방향성이 외삽에서도 유지된다</a:t>
+              <a:t>•  구조 prior → model-input ΔRUL&lt;0 100%</a:t>
             </a:r>
           </a:p>
           <a:p>
@@ -7023,7 +7817,7 @@
                 <a:latin typeface="Apple SD Gothic Neo"/>
                 <a:ea typeface="Apple SD Gothic Neo"/>
               </a:rPr>
-              <a:t>•  모델마다 epoch 맞춘 비교 · 같은 후처리</a:t>
+              <a:t>•  MonotoneLoadHead ablation으로 인과 확인</a:t>
             </a:r>
           </a:p>
           <a:p>
@@ -7040,7 +7834,7 @@
                 <a:latin typeface="Apple SD Gothic Neo"/>
                 <a:ea typeface="Apple SD Gothic Neo"/>
               </a:rPr>
-              <a:t>•  본편 외삽 체크리스트 4항 충족</a:t>
+              <a:t>•  본편 S30 체크 4항 충족</a:t>
             </a:r>
           </a:p>
         </p:txBody>
@@ -7183,7 +7977,7 @@
                 <a:latin typeface="Apple SD Gothic Neo"/>
                 <a:ea typeface="Apple SD Gothic Neo"/>
               </a:rPr>
-              <a:t>•  ‘데이터가 부하↑수명↓을 증명했다’</a:t>
+              <a:t>•  ‘데이터가 TRA↑⇒RUL↓ 증명’ (r≈0, ∂RUL/∂TRA=0)</a:t>
             </a:r>
           </a:p>
           <a:p>
@@ -7200,7 +7994,7 @@
                 <a:latin typeface="Apple SD Gothic Neo"/>
                 <a:ea typeface="Apple SD Gothic Neo"/>
               </a:rPr>
-              <a:t>•  ‘특정 loss 덕분에 방향이 생겼다’</a:t>
+              <a:t>•  ‘λ_tra·physics loss가 방향 생성’ (λ=0도 100%)</a:t>
             </a:r>
           </a:p>
           <a:p>
@@ -7217,7 +8011,24 @@
                 <a:latin typeface="Apple SD Gothic Neo"/>
                 <a:ea typeface="Apple SD Gothic Neo"/>
               </a:rPr>
-              <a:t>•  ‘라벨만 보면 물리 법칙이 입증됐다’</a:t>
+              <a:t>•  ‘PINN/PDE 물리 법칙 준수’</a:t>
+            </a:r>
+          </a:p>
+          <a:p>
+            <a:pPr algn="l">
+              <a:spcBef>
+                <a:spcPts val="300"/>
+              </a:spcBef>
+            </a:pPr>
+            <a:r>
+              <a:rPr sz="1100" b="0">
+                <a:solidFill>
+                  <a:srgbClr val="A0ADBC"/>
+                </a:solidFill>
+                <a:latin typeface="Apple SD Gothic Neo"/>
+                <a:ea typeface="Apple SD Gothic Neo"/>
+              </a:rPr>
+              <a:t>•  ‘C-MAPSS 전 split SOTA’</a:t>
             </a:r>
           </a:p>
         </p:txBody>
@@ -7336,7 +8147,7 @@
                 <a:latin typeface="Apple SD Gothic Neo"/>
                 <a:ea typeface="Apple SD Gothic Neo"/>
               </a:rPr>
-              <a:t>N-CMAPSS · 처음 보는 엔진 + 높은 부하에서 수명 예측</a:t>
+              <a:t>N-CMAPSS hard — unit×TRA 밖 (결합 외삽)</a:t>
             </a:r>
           </a:p>
         </p:txBody>
@@ -7455,7 +8266,7 @@
                 <a:latin typeface="Apple SD Gothic Neo"/>
                 <a:ea typeface="Apple SD Gothic Neo"/>
               </a:rPr>
-              <a:t>시간 단조 · 고부하 열화 · 건강−손상 분리</a:t>
+              <a:t>counterfactual 부하 prior → MonotoneLoadHead 구조</a:t>
             </a:r>
           </a:p>
         </p:txBody>
@@ -7538,7 +8349,7 @@
                 <a:latin typeface="Apple SD Gothic Neo"/>
                 <a:ea typeface="Apple SD Gothic Neo"/>
               </a:rPr>
-              <a:t>방법</a:t>
+              <a:t>loss</a:t>
             </a:r>
           </a:p>
         </p:txBody>
@@ -7574,7 +8385,7 @@
                 <a:latin typeface="Apple SD Gothic Neo"/>
                 <a:ea typeface="Apple SD Gothic Neo"/>
               </a:rPr>
-              <a:t>부하 단조 head · 건강 경로에서 부하 제거 · 단조 보정</a:t>
+              <a:t>L_RUL fit + L_physics 보조 — 방향은 구조</a:t>
             </a:r>
           </a:p>
         </p:txBody>
@@ -7693,7 +8504,7 @@
                 <a:latin typeface="Apple SD Gothic Neo"/>
                 <a:ea typeface="Apple SD Gothic Neo"/>
               </a:rPr>
-              <a:t>RMSE 3.4 · R² 0.97 — TabPFN 4.8보다 낮음</a:t>
+              <a:t>RMSE 3.43 vs TabPFN 4.79 · worst-seed 방어</a:t>
             </a:r>
           </a:p>
         </p:txBody>
@@ -7819,7 +8630,24 @@
                 <a:latin typeface="Apple SD Gothic Neo"/>
                 <a:ea typeface="Apple SD Gothic Neo"/>
               </a:rPr>
-              <a:t>밖을 버티는 건 데이터가 아니라 가정 — 그 가정을 구조에 넣고, hard에서 숫자로 확인했다</a:t>
+              <a:t>밖을 버티는 건 데이터가 아니라 구조 prior — physics loss는 fit 보조</a:t>
+            </a:r>
+          </a:p>
+          <a:p>
+            <a:pPr algn="l">
+              <a:spcBef>
+                <a:spcPts val="100"/>
+              </a:spcBef>
+            </a:pPr>
+            <a:r>
+              <a:rPr sz="1000" b="0">
+                <a:solidFill>
+                  <a:srgbClr val="B8C4D0"/>
+                </a:solidFill>
+                <a:latin typeface="Apple SD Gothic Neo"/>
+                <a:ea typeface="Apple SD Gothic Neo"/>
+              </a:rPr>
+              <a:t>본편 echo: 가정을 구조에 넣고, hard에서 검증</a:t>
             </a:r>
           </a:p>
         </p:txBody>

</xml_diff>